<commit_message>
Declare Calibri as the default font in the blank templates and fix their zip packaging, bump to 0.17.10-alpha (#32)
</commit_message>
<xml_diff>
--- a/src-tauri/templates/blank.pptx
+++ b/src-tauri/templates/blank.pptx
@@ -1,5 +1,5 @@
 
-<file path=ppt\presentation.xml><?xml version="1.0" encoding="utf-8"?>
+<file path=ppt/presentation.xml><?xml version="1.0" encoding="utf-8"?>
 <p:presentation xmlns:a="http://schemas.openxmlformats.org/drawingml/2006/main" xmlns:r="http://schemas.openxmlformats.org/officeDocument/2006/relationships" xmlns:p="http://schemas.openxmlformats.org/presentationml/2006/main">
   <p:sldMasterIdLst>
     <p:sldMasterId id="2147483648" r:id="rId1"/>
@@ -12,7 +12,7 @@
 </p:presentation>
 </file>
 
-<file path=ppt\slideLayouts\slideLayout1.xml><?xml version="1.0" encoding="utf-8"?>
+<file path=ppt/slideLayouts/slideLayout1.xml><?xml version="1.0" encoding="utf-8"?>
 <p:sldLayout xmlns:a="http://schemas.openxmlformats.org/drawingml/2006/main" xmlns:r="http://schemas.openxmlformats.org/officeDocument/2006/relationships" xmlns:p="http://schemas.openxmlformats.org/presentationml/2006/main" type="title">
   <p:cSld>
     <p:spTree>
@@ -27,7 +27,7 @@
 </p:sldLayout>
 </file>
 
-<file path=ppt\slideMasters\slideMaster1.xml><?xml version="1.0" encoding="utf-8"?>
+<file path=ppt/slideMasters/slideMaster1.xml><?xml version="1.0" encoding="utf-8"?>
 <p:sldMaster xmlns:a="http://schemas.openxmlformats.org/drawingml/2006/main" xmlns:r="http://schemas.openxmlformats.org/officeDocument/2006/relationships" xmlns:p="http://schemas.openxmlformats.org/presentationml/2006/main">
   <p:cSld>
     <p:bg>
@@ -54,7 +54,7 @@
 </p:sldMaster>
 </file>
 
-<file path=ppt\slides\slide1.xml><?xml version="1.0" encoding="utf-8"?>
+<file path=ppt/slides/slide1.xml><?xml version="1.0" encoding="utf-8"?>
 <p:sld xmlns:a="http://schemas.openxmlformats.org/drawingml/2006/main" xmlns:r="http://schemas.openxmlformats.org/officeDocument/2006/relationships" xmlns:p="http://schemas.openxmlformats.org/presentationml/2006/main">
   <p:cSld>
     <p:spTree>
@@ -125,7 +125,7 @@
 </p:sld>
 </file>
 
-<file path=ppt\theme\theme1.xml><?xml version="1.0" encoding="utf-8"?>
+<file path=ppt/theme/theme1.xml><?xml version="1.0" encoding="utf-8"?>
 <a:theme xmlns:a="http://schemas.openxmlformats.org/drawingml/2006/main" name="Blank">
   <a:themeElements>
     <a:clrScheme name="Office">

</xml_diff>